<commit_message>
Regenerate CMG presentation from corrected 50-min transcription
Updated proposal based on full meeting content:
- Market context: XM platform disruption, CMG's shrinking ad-hoc model
- Voice-to-research automation flow (Notta → survey design AI → MA)
- User segmentation: 85% automation / 15% power-user
- API-first integration (no hardware, no custom UI)
- PoC design with KPIs and budget scope
- Next actions with owners for early April MTG

https://claude.ai/code/session_01TRkHFS2izteTGUG9tXtCZE
</commit_message>
<xml_diff>
--- a/cross_marketing_notta_presentation.pptx
+++ b/cross_marketing_notta_presentation.pptx
@@ -15,6 +15,7 @@
     <p:sldId id="263" r:id="rId15"/>
     <p:sldId id="264" r:id="rId16"/>
     <p:sldId id="265" r:id="rId17"/>
+    <p:sldId id="266" r:id="rId18"/>
   </p:sldIdLst>
   <p:sldSz cx="12188952" cy="6858000" type="screen4x3"/>
   <p:notesSz cx="6858000" cy="9144000"/>
@@ -511,7 +512,77 @@
           <a:lstStyle/>
           <a:p>
             <a:r>
-              <a:t>冒頭で参加者の自己紹介と本日のゴール確認を行う</a:t>
+              <a:t>冒頭で議論の全体像を共有し、資料の読み方を説明する</a:t>
+            </a:r>
+          </a:p>
+        </p:txBody>
+      </p:sp>
+      <p:sp>
+        <p:nvSpPr>
+          <p:cNvPr id="4" name="Slide Number Placeholder 3"/>
+          <p:cNvSpPr>
+            <a:spLocks noGrp="1"/>
+          </p:cNvSpPr>
+          <p:nvPr>
+            <p:ph type="sldNum" idx="5" sz="quarter"/>
+          </p:nvPr>
+        </p:nvSpPr>
+        <p:spPr/>
+      </p:sp>
+    </p:spTree>
+  </p:cSld>
+  <p:clrMapOvr>
+    <a:masterClrMapping/>
+  </p:clrMapOvr>
+</p:notes>
+</file>
+
+<file path=ppt/notesSlides/notesSlide10.xml><?xml version="1.0" encoding="utf-8"?>
+<p:notes xmlns:a="http://schemas.openxmlformats.org/drawingml/2006/main" xmlns:p="http://schemas.openxmlformats.org/presentationml/2006/main" xmlns:r="http://schemas.openxmlformats.org/officeDocument/2006/relationships">
+  <p:cSld>
+    <p:spTree>
+      <p:nvGrpSpPr>
+        <p:cNvPr id="1" name=""/>
+        <p:cNvGrpSpPr/>
+        <p:nvPr/>
+      </p:nvGrpSpPr>
+      <p:grpSpPr>
+        <a:xfrm>
+          <a:off x="0" y="0"/>
+          <a:ext cx="0" cy="0"/>
+          <a:chOff x="0" y="0"/>
+          <a:chExt cx="0" cy="0"/>
+        </a:xfrm>
+      </p:grpSpPr>
+      <p:sp>
+        <p:nvSpPr>
+          <p:cNvPr id="2" name="Slide Image Placeholder 1"/>
+          <p:cNvSpPr>
+            <a:spLocks noGrp="1"/>
+          </p:cNvSpPr>
+          <p:nvPr>
+            <p:ph type="sldImg" idx="2"/>
+          </p:nvPr>
+        </p:nvSpPr>
+        <p:spPr/>
+      </p:sp>
+      <p:sp>
+        <p:nvSpPr>
+          <p:cNvPr id="3" name="Notes Placeholder 2"/>
+          <p:cNvSpPr>
+            <a:spLocks noGrp="1"/>
+          </p:cNvSpPr>
+          <p:nvPr>
+            <p:ph type="body" idx="3" sz="quarter"/>
+          </p:nvPr>
+        </p:nvSpPr>
+        <p:spPr/>
+        <p:txBody>
+          <a:bodyPr/>
+          <a:lstStyle/>
+          <a:p>
+            <a:r>
+              <a:t>アクションオーナーと期限を明確にして次回MTGで進捗確認できるようにする</a:t>
             </a:r>
           </a:p>
         </p:txBody>
@@ -581,7 +652,7 @@
           <a:lstStyle/>
           <a:p>
             <a:r>
-              <a:t>CMG の事業規模（年間調査件数・社員数）をヒアリングして数値を更新する</a:t>
+              <a:t>CMGが自ら認識している事業シュリンクリスクを客観的に示す</a:t>
             </a:r>
           </a:p>
         </p:txBody>
@@ -651,7 +722,7 @@
           <a:lstStyle/>
           <a:p>
             <a:r>
-              <a:t>デモ動画を用意して実際の使用感を見せると効果的</a:t>
+              <a:t>CMGの中期経営計画「マーケティングDX」と直結していることを強調</a:t>
             </a:r>
           </a:p>
         </p:txBody>
@@ -721,7 +792,7 @@
           <a:lstStyle/>
           <a:p>
             <a:r>
-              <a:t>各部門の担当キーパーソンへの個別訴求ポイントを準備しておく</a:t>
+              <a:t>クライアント側の課題として、CMG経由でエンドユーザー企業の痛みポイントを示す</a:t>
             </a:r>
           </a:p>
         </p:txBody>
@@ -791,7 +862,7 @@
           <a:lstStyle/>
           <a:p>
             <a:r>
-              <a:t>CMG の実際の外注費・社員数を確認して数値を更新する</a:t>
+              <a:t>フロー図を別途用意して視覚的に説明できると効果的</a:t>
             </a:r>
           </a:p>
         </p:txBody>
@@ -861,7 +932,7 @@
           <a:lstStyle/>
           <a:p>
             <a:r>
-              <a:t>情報セキュリティ担当者が関与する場合は詳細資料を別途用意</a:t>
+              <a:t>セグメント比率はCMGの岡崎様発言（85%：15%）をそのまま引用</a:t>
             </a:r>
           </a:p>
         </p:txBody>
@@ -931,7 +1002,7 @@
           <a:lstStyle/>
           <a:p>
             <a:r>
-              <a:t>パイロット部門の選定についてヒアリングを行う</a:t>
+              <a:t>後戻りできない大規模開発を避け、スモールスタートで検証する方針</a:t>
             </a:r>
           </a:p>
         </p:txBody>
@@ -1001,7 +1072,7 @@
           <a:lstStyle/>
           <a:p>
             <a:r>
-              <a:t>CMG の規模には Business または Enterprise が最適。具体的な見積もりを次回提示予定</a:t>
+              <a:t>双方にとっての戦略的意義を対等に示すことで協業モチベーションを高める</a:t>
             </a:r>
           </a:p>
         </p:txBody>
@@ -1071,7 +1142,7 @@
           <a:lstStyle/>
           <a:p>
             <a:r>
-              <a:t>クロージング：本日中に担当者へトライアルアカウントを発行する旨を確認</a:t>
+              <a:t>予算感（数百万円規模）はCMG岡崎様の言及に基づく。次回MTGで具体化</a:t>
             </a:r>
           </a:p>
         </p:txBody>
@@ -4156,7 +4227,8 @@
                 </a:solidFill>
                 <a:latin typeface="Noto Sans"/>
               </a:rPr>
-              <a:t>Notta 導入提案書</a:t>
+              <a:t>Notta × クロスマーケティンググループ
+協業提案書</a:t>
             </a:r>
           </a:p>
         </p:txBody>
@@ -4232,8 +4304,7 @@
                 </a:solidFill>
                 <a:latin typeface="Noto Sans"/>
               </a:rPr>
-              <a:t>クロスマーケティンググループ様向け
-AI 文字起こし・議事録自動生成ソリューション
+              <a:t>音声データ起点の次世代リサーチプラットフォーム構想
 2026年3月</a:t>
             </a:r>
           </a:p>
@@ -4293,7 +4364,7 @@
                 </a:solidFill>
                 <a:latin typeface="Noto Sans"/>
               </a:rPr>
-              <a:t>次のステップ</a:t>
+              <a:t>PoC設計の方向性</a:t>
             </a:r>
           </a:p>
         </p:txBody>
@@ -4369,7 +4440,7 @@
                 </a:solidFill>
                 <a:latin typeface="Noto Sans"/>
               </a:rPr>
-              <a:t>まずは無料トライアルでリサーチ現場での効果を実感してください</a:t>
+              <a:t>数百万円規模の小さな投資で技術検証を完了し、双方がリスクを限定しながら協業の実現可能性を確認する</a:t>
             </a:r>
           </a:p>
         </p:txBody>
@@ -4383,16 +4454,18 @@
         <p:spPr>
           <a:xfrm>
             <a:off x="548640" y="1897380"/>
-            <a:ext cx="3587496" cy="4640580"/>
+            <a:ext cx="5463540" cy="2237994"/>
           </a:xfrm>
           <a:prstGeom prst="rect">
             <a:avLst/>
           </a:prstGeom>
           <a:solidFill>
-            <a:srgbClr val="F5F5F5"/>
+            <a:srgbClr val="FFFFFF"/>
           </a:solidFill>
-          <a:ln>
-            <a:noFill/>
+          <a:ln w="9525">
+            <a:solidFill>
+              <a:srgbClr val="E0E0E0"/>
+            </a:solidFill>
           </a:ln>
         </p:spPr>
         <p:style>
@@ -4426,7 +4499,7 @@
         <p:spPr>
           <a:xfrm>
             <a:off x="713232" y="2061972"/>
-            <a:ext cx="3258312" cy="347472"/>
+            <a:ext cx="5134356" cy="347472"/>
           </a:xfrm>
           <a:prstGeom prst="rect">
             <a:avLst/>
@@ -4445,7 +4518,7 @@
                 </a:solidFill>
                 <a:latin typeface="Noto Sans"/>
               </a:rPr>
-              <a:t>無料トライアル申込</a:t>
+              <a:t>検証対象フロー</a:t>
             </a:r>
           </a:p>
         </p:txBody>
@@ -4459,7 +4532,7 @@
         <p:spPr>
           <a:xfrm>
             <a:off x="713232" y="2446020"/>
-            <a:ext cx="3258312" cy="3927348"/>
+            <a:ext cx="5134356" cy="1524762"/>
           </a:xfrm>
           <a:prstGeom prst="rect">
             <a:avLst/>
@@ -4478,8 +4551,7 @@
                 </a:solidFill>
                 <a:latin typeface="Noto Sans"/>
               </a:rPr>
-              <a:t>14 日間・全機能無料トライアル。クレジットカード不要。
-本日中にアカウント発行可能</a:t>
+              <a:t>「会議音声 → Notta文字起こし → CMG調査設計AI → 秋雲配信」の一気通貫フローをプロトタイプ実装</a:t>
             </a:r>
           </a:p>
         </p:txBody>
@@ -4492,17 +4564,19 @@
         </p:nvSpPr>
         <p:spPr>
           <a:xfrm>
-            <a:off x="4300728" y="1897380"/>
-            <a:ext cx="3587496" cy="4640580"/>
+            <a:off x="6176772" y="1897380"/>
+            <a:ext cx="5463540" cy="2237994"/>
           </a:xfrm>
           <a:prstGeom prst="rect">
             <a:avLst/>
           </a:prstGeom>
           <a:solidFill>
-            <a:srgbClr val="F5F5F5"/>
+            <a:srgbClr val="FFFFFF"/>
           </a:solidFill>
-          <a:ln>
-            <a:noFill/>
+          <a:ln w="9525">
+            <a:solidFill>
+              <a:srgbClr val="E0E0E0"/>
+            </a:solidFill>
           </a:ln>
         </p:spPr>
         <p:style>
@@ -4535,8 +4609,8 @@
         </p:nvSpPr>
         <p:spPr>
           <a:xfrm>
-            <a:off x="4465320" y="2061972"/>
-            <a:ext cx="3258312" cy="347472"/>
+            <a:off x="6341364" y="2061972"/>
+            <a:ext cx="5134356" cy="347472"/>
           </a:xfrm>
           <a:prstGeom prst="rect">
             <a:avLst/>
@@ -4555,7 +4629,7 @@
                 </a:solidFill>
                 <a:latin typeface="Noto Sans"/>
               </a:rPr>
-              <a:t>パイロット設計ミーティング</a:t>
+              <a:t>CMG側の準備</a:t>
             </a:r>
           </a:p>
         </p:txBody>
@@ -4568,8 +4642,8 @@
         </p:nvSpPr>
         <p:spPr>
           <a:xfrm>
-            <a:off x="4465320" y="2446020"/>
-            <a:ext cx="3258312" cy="3927348"/>
+            <a:off x="6341364" y="2446020"/>
+            <a:ext cx="5134356" cy="1524762"/>
           </a:xfrm>
           <a:prstGeom prst="rect">
             <a:avLst/>
@@ -4588,7 +4662,8 @@
                 </a:solidFill>
                 <a:latin typeface="Noto Sans"/>
               </a:rPr>
-              <a:t>トライアル対象部門・KPI・ユースケースを確定する打合せを来週設定</a:t>
+              <a:t>・2つのプロダクト（秋雲・リサーチャー向けプロトタイプ）のデモを次回Notta側に共有
+・調査設計AIの入力仕様・出力仕様を整理</a:t>
             </a:r>
           </a:p>
         </p:txBody>
@@ -4601,17 +4676,19 @@
         </p:nvSpPr>
         <p:spPr>
           <a:xfrm>
-            <a:off x="8052816" y="1897380"/>
-            <a:ext cx="3587496" cy="4640580"/>
+            <a:off x="548640" y="4299966"/>
+            <a:ext cx="5463540" cy="2237994"/>
           </a:xfrm>
           <a:prstGeom prst="rect">
             <a:avLst/>
           </a:prstGeom>
           <a:solidFill>
-            <a:srgbClr val="F5F5F5"/>
+            <a:srgbClr val="FFFFFF"/>
           </a:solidFill>
-          <a:ln>
-            <a:noFill/>
+          <a:ln w="9525">
+            <a:solidFill>
+              <a:srgbClr val="E0E0E0"/>
+            </a:solidFill>
           </a:ln>
         </p:spPr>
         <p:style>
@@ -4644,8 +4721,8 @@
         </p:nvSpPr>
         <p:spPr>
           <a:xfrm>
-            <a:off x="8217408" y="2061972"/>
-            <a:ext cx="3258312" cy="347472"/>
+            <a:off x="713232" y="4464558"/>
+            <a:ext cx="5134356" cy="347472"/>
           </a:xfrm>
           <a:prstGeom prst="rect">
             <a:avLst/>
@@ -4664,7 +4741,7 @@
                 </a:solidFill>
                 <a:latin typeface="Noto Sans"/>
               </a:rPr>
-              <a:t>技術・セキュリティレビュー</a:t>
+              <a:t>Notta側の準備</a:t>
             </a:r>
           </a:p>
         </p:txBody>
@@ -4677,8 +4754,8 @@
         </p:nvSpPr>
         <p:spPr>
           <a:xfrm>
-            <a:off x="8217408" y="2446020"/>
-            <a:ext cx="3258312" cy="3927348"/>
+            <a:off x="713232" y="4848606"/>
+            <a:ext cx="5134356" cy="1524762"/>
           </a:xfrm>
           <a:prstGeom prst="rect">
             <a:avLst/>
@@ -4697,7 +4774,701 @@
                 </a:solidFill>
                 <a:latin typeface="Noto Sans"/>
               </a:rPr>
-              <a:t>IT / 情報セキュリティ部門向けの詳細資料・Q&amp;A セッションを別途実施</a:t>
+              <a:t>・CMGユースケース向けのプロンプトテンプレート設計
+・API出力フォーマット（JSON）の設計
+・Nottaブレインのカスタム設定オプション整備</a:t>
+            </a:r>
+          </a:p>
+        </p:txBody>
+      </p:sp>
+      <p:sp>
+        <p:nvSpPr>
+          <p:cNvPr id="14" name="Rectangle 13"/>
+          <p:cNvSpPr/>
+          <p:nvPr/>
+        </p:nvSpPr>
+        <p:spPr>
+          <a:xfrm>
+            <a:off x="6176772" y="4299966"/>
+            <a:ext cx="5463540" cy="2237994"/>
+          </a:xfrm>
+          <a:prstGeom prst="rect">
+            <a:avLst/>
+          </a:prstGeom>
+          <a:solidFill>
+            <a:srgbClr val="FFFFFF"/>
+          </a:solidFill>
+          <a:ln w="9525">
+            <a:solidFill>
+              <a:srgbClr val="E0E0E0"/>
+            </a:solidFill>
+          </a:ln>
+        </p:spPr>
+        <p:style>
+          <a:lnRef idx="1">
+            <a:schemeClr val="accent1"/>
+          </a:lnRef>
+          <a:fillRef idx="3">
+            <a:schemeClr val="accent1"/>
+          </a:fillRef>
+          <a:effectRef idx="2">
+            <a:schemeClr val="accent1"/>
+          </a:effectRef>
+          <a:fontRef idx="minor">
+            <a:schemeClr val="lt1"/>
+          </a:fontRef>
+        </p:style>
+        <p:txBody>
+          <a:bodyPr rtlCol="0" anchor="ctr"/>
+          <a:lstStyle/>
+          <a:p>
+            <a:pPr algn="ctr"/>
+          </a:p>
+        </p:txBody>
+      </p:sp>
+      <p:sp>
+        <p:nvSpPr>
+          <p:cNvPr id="15" name="TextBox 14"/>
+          <p:cNvSpPr txBox="1"/>
+          <p:nvPr/>
+        </p:nvSpPr>
+        <p:spPr>
+          <a:xfrm>
+            <a:off x="6341364" y="4464558"/>
+            <a:ext cx="5134356" cy="347472"/>
+          </a:xfrm>
+          <a:prstGeom prst="rect">
+            <a:avLst/>
+          </a:prstGeom>
+          <a:noFill/>
+        </p:spPr>
+        <p:txBody>
+          <a:bodyPr wrap="square"/>
+          <a:lstStyle/>
+          <a:p>
+            <a:pPr algn="l"/>
+            <a:r>
+              <a:rPr sz="1800" b="1">
+                <a:solidFill>
+                  <a:srgbClr val="2180FF"/>
+                </a:solidFill>
+                <a:latin typeface="Noto Sans"/>
+              </a:rPr>
+              <a:t>成功基準（KPI）</a:t>
+            </a:r>
+          </a:p>
+        </p:txBody>
+      </p:sp>
+      <p:sp>
+        <p:nvSpPr>
+          <p:cNvPr id="16" name="TextBox 15"/>
+          <p:cNvSpPr txBox="1"/>
+          <p:nvPr/>
+        </p:nvSpPr>
+        <p:spPr>
+          <a:xfrm>
+            <a:off x="6341364" y="4848606"/>
+            <a:ext cx="5134356" cy="1524762"/>
+          </a:xfrm>
+          <a:prstGeom prst="rect">
+            <a:avLst/>
+          </a:prstGeom>
+          <a:noFill/>
+        </p:spPr>
+        <p:txBody>
+          <a:bodyPr wrap="square"/>
+          <a:lstStyle/>
+          <a:p>
+            <a:pPr algn="l"/>
+            <a:r>
+              <a:rPr sz="1200" b="0">
+                <a:solidFill>
+                  <a:srgbClr val="262626"/>
+                </a:solidFill>
+                <a:latin typeface="Noto Sans"/>
+              </a:rPr>
+              <a:t>・調査設計リードタイム：現状比70%短縮
+・設問品質スコア：リサーチャー評価による
+・ユーザビリティ：マーケター層の操作完結率</a:t>
+            </a:r>
+          </a:p>
+        </p:txBody>
+      </p:sp>
+    </p:spTree>
+  </p:cSld>
+  <p:clrMapOvr>
+    <a:masterClrMapping/>
+  </p:clrMapOvr>
+</p:sld>
+</file>
+
+<file path=ppt/slides/slide11.xml><?xml version="1.0" encoding="utf-8"?>
+<p:sld xmlns:a="http://schemas.openxmlformats.org/drawingml/2006/main" xmlns:p="http://schemas.openxmlformats.org/presentationml/2006/main" xmlns:r="http://schemas.openxmlformats.org/officeDocument/2006/relationships">
+  <p:cSld>
+    <p:bg>
+      <p:bgPr>
+        <a:solidFill>
+          <a:srgbClr val="FFFFFF"/>
+        </a:solidFill>
+        <a:effectLst/>
+      </p:bgPr>
+    </p:bg>
+    <p:spTree>
+      <p:nvGrpSpPr>
+        <p:cNvPr id="1" name=""/>
+        <p:cNvGrpSpPr/>
+        <p:nvPr/>
+      </p:nvGrpSpPr>
+      <p:grpSpPr/>
+      <p:sp>
+        <p:nvSpPr>
+          <p:cNvPr id="2" name="TextBox 1"/>
+          <p:cNvSpPr txBox="1"/>
+          <p:nvPr/>
+        </p:nvSpPr>
+        <p:spPr>
+          <a:xfrm>
+            <a:off x="548640" y="320040"/>
+            <a:ext cx="11091672" cy="411480"/>
+          </a:xfrm>
+          <a:prstGeom prst="rect">
+            <a:avLst/>
+          </a:prstGeom>
+          <a:noFill/>
+        </p:spPr>
+        <p:txBody>
+          <a:bodyPr wrap="square"/>
+          <a:lstStyle/>
+          <a:p>
+            <a:pPr algn="l"/>
+            <a:r>
+              <a:rPr sz="1600" b="0">
+                <a:solidFill>
+                  <a:srgbClr val="2180FF"/>
+                </a:solidFill>
+                <a:latin typeface="Noto Sans"/>
+              </a:rPr>
+              <a:t>次のアクション</a:t>
+            </a:r>
+          </a:p>
+        </p:txBody>
+      </p:sp>
+      <p:sp>
+        <p:nvSpPr>
+          <p:cNvPr id="3" name="Rectangle 2"/>
+          <p:cNvSpPr/>
+          <p:nvPr/>
+        </p:nvSpPr>
+        <p:spPr>
+          <a:xfrm>
+            <a:off x="548640" y="841248"/>
+            <a:ext cx="11091672" cy="13716"/>
+          </a:xfrm>
+          <a:prstGeom prst="rect">
+            <a:avLst/>
+          </a:prstGeom>
+          <a:solidFill>
+            <a:srgbClr val="D0D0D0"/>
+          </a:solidFill>
+          <a:ln>
+            <a:noFill/>
+          </a:ln>
+        </p:spPr>
+        <p:style>
+          <a:lnRef idx="1">
+            <a:schemeClr val="accent1"/>
+          </a:lnRef>
+          <a:fillRef idx="3">
+            <a:schemeClr val="accent1"/>
+          </a:fillRef>
+          <a:effectRef idx="2">
+            <a:schemeClr val="accent1"/>
+          </a:effectRef>
+          <a:fontRef idx="minor">
+            <a:schemeClr val="lt1"/>
+          </a:fontRef>
+        </p:style>
+        <p:txBody>
+          <a:bodyPr rtlCol="0" anchor="ctr"/>
+          <a:lstStyle/>
+          <a:p>
+            <a:pPr algn="ctr"/>
+          </a:p>
+        </p:txBody>
+      </p:sp>
+      <p:sp>
+        <p:nvSpPr>
+          <p:cNvPr id="4" name="TextBox 3"/>
+          <p:cNvSpPr txBox="1"/>
+          <p:nvPr/>
+        </p:nvSpPr>
+        <p:spPr>
+          <a:xfrm>
+            <a:off x="548640" y="982980"/>
+            <a:ext cx="11091672" cy="685800"/>
+          </a:xfrm>
+          <a:prstGeom prst="rect">
+            <a:avLst/>
+          </a:prstGeom>
+          <a:noFill/>
+        </p:spPr>
+        <p:txBody>
+          <a:bodyPr wrap="square"/>
+          <a:lstStyle/>
+          <a:p>
+            <a:pPr algn="l"/>
+            <a:r>
+              <a:rPr sz="2000" b="1">
+                <a:solidFill>
+                  <a:srgbClr val="262626"/>
+                </a:solidFill>
+                <a:latin typeface="Noto Sans"/>
+              </a:rPr>
+              <a:t>4月頭のMTGまでに両社が準備を完了し、具体的なPoC設計・予算合意へ進む</a:t>
+            </a:r>
+          </a:p>
+        </p:txBody>
+      </p:sp>
+      <p:sp>
+        <p:nvSpPr>
+          <p:cNvPr id="5" name="Rectangle 4"/>
+          <p:cNvSpPr/>
+          <p:nvPr/>
+        </p:nvSpPr>
+        <p:spPr>
+          <a:xfrm>
+            <a:off x="548640" y="1897380"/>
+            <a:ext cx="5463540" cy="2237994"/>
+          </a:xfrm>
+          <a:prstGeom prst="rect">
+            <a:avLst/>
+          </a:prstGeom>
+          <a:solidFill>
+            <a:srgbClr val="FFFFFF"/>
+          </a:solidFill>
+          <a:ln w="9525">
+            <a:solidFill>
+              <a:srgbClr val="E0E0E0"/>
+            </a:solidFill>
+          </a:ln>
+        </p:spPr>
+        <p:style>
+          <a:lnRef idx="1">
+            <a:schemeClr val="accent1"/>
+          </a:lnRef>
+          <a:fillRef idx="3">
+            <a:schemeClr val="accent1"/>
+          </a:fillRef>
+          <a:effectRef idx="2">
+            <a:schemeClr val="accent1"/>
+          </a:effectRef>
+          <a:fontRef idx="minor">
+            <a:schemeClr val="lt1"/>
+          </a:fontRef>
+        </p:style>
+        <p:txBody>
+          <a:bodyPr rtlCol="0" anchor="ctr"/>
+          <a:lstStyle/>
+          <a:p>
+            <a:pPr algn="ctr"/>
+          </a:p>
+        </p:txBody>
+      </p:sp>
+      <p:sp>
+        <p:nvSpPr>
+          <p:cNvPr id="6" name="TextBox 5"/>
+          <p:cNvSpPr txBox="1"/>
+          <p:nvPr/>
+        </p:nvSpPr>
+        <p:spPr>
+          <a:xfrm>
+            <a:off x="713232" y="2061972"/>
+            <a:ext cx="5134356" cy="347472"/>
+          </a:xfrm>
+          <a:prstGeom prst="rect">
+            <a:avLst/>
+          </a:prstGeom>
+          <a:noFill/>
+        </p:spPr>
+        <p:txBody>
+          <a:bodyPr wrap="square"/>
+          <a:lstStyle/>
+          <a:p>
+            <a:pPr algn="l"/>
+            <a:r>
+              <a:rPr sz="1800" b="1">
+                <a:solidFill>
+                  <a:srgbClr val="2180FF"/>
+                </a:solidFill>
+                <a:latin typeface="Noto Sans"/>
+              </a:rPr>
+              <a:t>【CMG】プロダクトデモ準備</a:t>
+            </a:r>
+          </a:p>
+        </p:txBody>
+      </p:sp>
+      <p:sp>
+        <p:nvSpPr>
+          <p:cNvPr id="7" name="TextBox 6"/>
+          <p:cNvSpPr txBox="1"/>
+          <p:nvPr/>
+        </p:nvSpPr>
+        <p:spPr>
+          <a:xfrm>
+            <a:off x="713232" y="2446020"/>
+            <a:ext cx="5134356" cy="1524762"/>
+          </a:xfrm>
+          <a:prstGeom prst="rect">
+            <a:avLst/>
+          </a:prstGeom>
+          <a:noFill/>
+        </p:spPr>
+        <p:txBody>
+          <a:bodyPr wrap="square"/>
+          <a:lstStyle/>
+          <a:p>
+            <a:pPr algn="l"/>
+            <a:r>
+              <a:rPr sz="1200" b="0">
+                <a:solidFill>
+                  <a:srgbClr val="262626"/>
+                </a:solidFill>
+                <a:latin typeface="Noto Sans"/>
+              </a:rPr>
+              <a:t>秋雲・リサーチャー向けプロトタイプの画面デモをNotta側に共有。API連携の技術要件を整理（担当：岡崎様）</a:t>
+            </a:r>
+          </a:p>
+        </p:txBody>
+      </p:sp>
+      <p:sp>
+        <p:nvSpPr>
+          <p:cNvPr id="8" name="Rectangle 7"/>
+          <p:cNvSpPr/>
+          <p:nvPr/>
+        </p:nvSpPr>
+        <p:spPr>
+          <a:xfrm>
+            <a:off x="6176772" y="1897380"/>
+            <a:ext cx="5463540" cy="2237994"/>
+          </a:xfrm>
+          <a:prstGeom prst="rect">
+            <a:avLst/>
+          </a:prstGeom>
+          <a:solidFill>
+            <a:srgbClr val="FFFFFF"/>
+          </a:solidFill>
+          <a:ln w="9525">
+            <a:solidFill>
+              <a:srgbClr val="E0E0E0"/>
+            </a:solidFill>
+          </a:ln>
+        </p:spPr>
+        <p:style>
+          <a:lnRef idx="1">
+            <a:schemeClr val="accent1"/>
+          </a:lnRef>
+          <a:fillRef idx="3">
+            <a:schemeClr val="accent1"/>
+          </a:fillRef>
+          <a:effectRef idx="2">
+            <a:schemeClr val="accent1"/>
+          </a:effectRef>
+          <a:fontRef idx="minor">
+            <a:schemeClr val="lt1"/>
+          </a:fontRef>
+        </p:style>
+        <p:txBody>
+          <a:bodyPr rtlCol="0" anchor="ctr"/>
+          <a:lstStyle/>
+          <a:p>
+            <a:pPr algn="ctr"/>
+          </a:p>
+        </p:txBody>
+      </p:sp>
+      <p:sp>
+        <p:nvSpPr>
+          <p:cNvPr id="9" name="TextBox 8"/>
+          <p:cNvSpPr txBox="1"/>
+          <p:nvPr/>
+        </p:nvSpPr>
+        <p:spPr>
+          <a:xfrm>
+            <a:off x="6341364" y="2061972"/>
+            <a:ext cx="5134356" cy="347472"/>
+          </a:xfrm>
+          <a:prstGeom prst="rect">
+            <a:avLst/>
+          </a:prstGeom>
+          <a:noFill/>
+        </p:spPr>
+        <p:txBody>
+          <a:bodyPr wrap="square"/>
+          <a:lstStyle/>
+          <a:p>
+            <a:pPr algn="l"/>
+            <a:r>
+              <a:rPr sz="1800" b="1">
+                <a:solidFill>
+                  <a:srgbClr val="2180FF"/>
+                </a:solidFill>
+                <a:latin typeface="Noto Sans"/>
+              </a:rPr>
+              <a:t>【Notta】PoC提案書作成</a:t>
+            </a:r>
+          </a:p>
+        </p:txBody>
+      </p:sp>
+      <p:sp>
+        <p:nvSpPr>
+          <p:cNvPr id="10" name="TextBox 9"/>
+          <p:cNvSpPr txBox="1"/>
+          <p:nvPr/>
+        </p:nvSpPr>
+        <p:spPr>
+          <a:xfrm>
+            <a:off x="6341364" y="2446020"/>
+            <a:ext cx="5134356" cy="1524762"/>
+          </a:xfrm>
+          <a:prstGeom prst="rect">
+            <a:avLst/>
+          </a:prstGeom>
+          <a:noFill/>
+        </p:spPr>
+        <p:txBody>
+          <a:bodyPr wrap="square"/>
+          <a:lstStyle/>
+          <a:p>
+            <a:pPr algn="l"/>
+            <a:r>
+              <a:rPr sz="1200" b="0">
+                <a:solidFill>
+                  <a:srgbClr val="262626"/>
+                </a:solidFill>
+                <a:latin typeface="Noto Sans"/>
+              </a:rPr>
+              <a:t>本日の議論を踏まえたPoC設計書を作成。スコープ・工数・予算感・KPIを明記（担当：河野・奥寺）</a:t>
+            </a:r>
+          </a:p>
+        </p:txBody>
+      </p:sp>
+      <p:sp>
+        <p:nvSpPr>
+          <p:cNvPr id="11" name="Rectangle 10"/>
+          <p:cNvSpPr/>
+          <p:nvPr/>
+        </p:nvSpPr>
+        <p:spPr>
+          <a:xfrm>
+            <a:off x="548640" y="4299966"/>
+            <a:ext cx="5463540" cy="2237994"/>
+          </a:xfrm>
+          <a:prstGeom prst="rect">
+            <a:avLst/>
+          </a:prstGeom>
+          <a:solidFill>
+            <a:srgbClr val="FFFFFF"/>
+          </a:solidFill>
+          <a:ln w="9525">
+            <a:solidFill>
+              <a:srgbClr val="E0E0E0"/>
+            </a:solidFill>
+          </a:ln>
+        </p:spPr>
+        <p:style>
+          <a:lnRef idx="1">
+            <a:schemeClr val="accent1"/>
+          </a:lnRef>
+          <a:fillRef idx="3">
+            <a:schemeClr val="accent1"/>
+          </a:fillRef>
+          <a:effectRef idx="2">
+            <a:schemeClr val="accent1"/>
+          </a:effectRef>
+          <a:fontRef idx="minor">
+            <a:schemeClr val="lt1"/>
+          </a:fontRef>
+        </p:style>
+        <p:txBody>
+          <a:bodyPr rtlCol="0" anchor="ctr"/>
+          <a:lstStyle/>
+          <a:p>
+            <a:pPr algn="ctr"/>
+          </a:p>
+        </p:txBody>
+      </p:sp>
+      <p:sp>
+        <p:nvSpPr>
+          <p:cNvPr id="12" name="TextBox 11"/>
+          <p:cNvSpPr txBox="1"/>
+          <p:nvPr/>
+        </p:nvSpPr>
+        <p:spPr>
+          <a:xfrm>
+            <a:off x="713232" y="4464558"/>
+            <a:ext cx="5134356" cy="347472"/>
+          </a:xfrm>
+          <a:prstGeom prst="rect">
+            <a:avLst/>
+          </a:prstGeom>
+          <a:noFill/>
+        </p:spPr>
+        <p:txBody>
+          <a:bodyPr wrap="square"/>
+          <a:lstStyle/>
+          <a:p>
+            <a:pPr algn="l"/>
+            <a:r>
+              <a:rPr sz="1800" b="1">
+                <a:solidFill>
+                  <a:srgbClr val="2180FF"/>
+                </a:solidFill>
+                <a:latin typeface="Noto Sans"/>
+              </a:rPr>
+              <a:t>【双方】次回MTG設定</a:t>
+            </a:r>
+          </a:p>
+        </p:txBody>
+      </p:sp>
+      <p:sp>
+        <p:nvSpPr>
+          <p:cNvPr id="13" name="TextBox 12"/>
+          <p:cNvSpPr txBox="1"/>
+          <p:nvPr/>
+        </p:nvSpPr>
+        <p:spPr>
+          <a:xfrm>
+            <a:off x="713232" y="4848606"/>
+            <a:ext cx="5134356" cy="1524762"/>
+          </a:xfrm>
+          <a:prstGeom prst="rect">
+            <a:avLst/>
+          </a:prstGeom>
+          <a:noFill/>
+        </p:spPr>
+        <p:txBody>
+          <a:bodyPr wrap="square"/>
+          <a:lstStyle/>
+          <a:p>
+            <a:pPr algn="l"/>
+            <a:r>
+              <a:rPr sz="1200" b="0">
+                <a:solidFill>
+                  <a:srgbClr val="262626"/>
+                </a:solidFill>
+                <a:latin typeface="Noto Sans"/>
+              </a:rPr>
+              <a:t>4月第1週にPoC設計確認MTGを設定。技術担当者同士のテクニカルレビューも並行して実施</a:t>
+            </a:r>
+          </a:p>
+        </p:txBody>
+      </p:sp>
+      <p:sp>
+        <p:nvSpPr>
+          <p:cNvPr id="14" name="Rectangle 13"/>
+          <p:cNvSpPr/>
+          <p:nvPr/>
+        </p:nvSpPr>
+        <p:spPr>
+          <a:xfrm>
+            <a:off x="6176772" y="4299966"/>
+            <a:ext cx="5463540" cy="2237994"/>
+          </a:xfrm>
+          <a:prstGeom prst="rect">
+            <a:avLst/>
+          </a:prstGeom>
+          <a:solidFill>
+            <a:srgbClr val="FFFFFF"/>
+          </a:solidFill>
+          <a:ln w="9525">
+            <a:solidFill>
+              <a:srgbClr val="E0E0E0"/>
+            </a:solidFill>
+          </a:ln>
+        </p:spPr>
+        <p:style>
+          <a:lnRef idx="1">
+            <a:schemeClr val="accent1"/>
+          </a:lnRef>
+          <a:fillRef idx="3">
+            <a:schemeClr val="accent1"/>
+          </a:fillRef>
+          <a:effectRef idx="2">
+            <a:schemeClr val="accent1"/>
+          </a:effectRef>
+          <a:fontRef idx="minor">
+            <a:schemeClr val="lt1"/>
+          </a:fontRef>
+        </p:style>
+        <p:txBody>
+          <a:bodyPr rtlCol="0" anchor="ctr"/>
+          <a:lstStyle/>
+          <a:p>
+            <a:pPr algn="ctr"/>
+          </a:p>
+        </p:txBody>
+      </p:sp>
+      <p:sp>
+        <p:nvSpPr>
+          <p:cNvPr id="15" name="TextBox 14"/>
+          <p:cNvSpPr txBox="1"/>
+          <p:nvPr/>
+        </p:nvSpPr>
+        <p:spPr>
+          <a:xfrm>
+            <a:off x="6341364" y="4464558"/>
+            <a:ext cx="5134356" cy="347472"/>
+          </a:xfrm>
+          <a:prstGeom prst="rect">
+            <a:avLst/>
+          </a:prstGeom>
+          <a:noFill/>
+        </p:spPr>
+        <p:txBody>
+          <a:bodyPr wrap="square"/>
+          <a:lstStyle/>
+          <a:p>
+            <a:pPr algn="l"/>
+            <a:r>
+              <a:rPr sz="1800" b="1">
+                <a:solidFill>
+                  <a:srgbClr val="2180FF"/>
+                </a:solidFill>
+                <a:latin typeface="Noto Sans"/>
+              </a:rPr>
+              <a:t>【双方】社内稟議・予算確保</a:t>
+            </a:r>
+          </a:p>
+        </p:txBody>
+      </p:sp>
+      <p:sp>
+        <p:nvSpPr>
+          <p:cNvPr id="16" name="TextBox 15"/>
+          <p:cNvSpPr txBox="1"/>
+          <p:nvPr/>
+        </p:nvSpPr>
+        <p:spPr>
+          <a:xfrm>
+            <a:off x="6341364" y="4848606"/>
+            <a:ext cx="5134356" cy="1524762"/>
+          </a:xfrm>
+          <a:prstGeom prst="rect">
+            <a:avLst/>
+          </a:prstGeom>
+          <a:noFill/>
+        </p:spPr>
+        <p:txBody>
+          <a:bodyPr wrap="square"/>
+          <a:lstStyle/>
+          <a:p>
+            <a:pPr algn="l"/>
+            <a:r>
+              <a:rPr sz="1200" b="0">
+                <a:solidFill>
+                  <a:srgbClr val="262626"/>
+                </a:solidFill>
+                <a:latin typeface="Noto Sans"/>
+              </a:rPr>
+              <a:t>PoC実施に向けた社内承認プロセスを開始。Notta側は開発リソースの確保、CMG側は新規事業予算の確認</a:t>
             </a:r>
           </a:p>
         </p:txBody>
@@ -4756,7 +5527,7 @@
                 </a:solidFill>
                 <a:latin typeface="Noto Sans"/>
               </a:rPr>
-              <a:t>本日のアジェンダ</a:t>
+              <a:t>本日の議論サマリー</a:t>
             </a:r>
           </a:p>
         </p:txBody>
@@ -4832,7 +5603,7 @@
                 </a:solidFill>
                 <a:latin typeface="Noto Sans"/>
               </a:rPr>
-              <a:t>Notta が CMG の業務効率化と情報活用をどう変えるかをご提案します</a:t>
+              <a:t>50分の議論を通じ、音声データを起点とした「リサーチ自動化フロー」の方向性が合致。次回PoC設計へ進む</a:t>
             </a:r>
           </a:p>
         </p:txBody>
@@ -4910,7 +5681,7 @@
                 </a:solidFill>
                 <a:latin typeface="Noto Sans"/>
               </a:rPr>
-              <a:t>01　課題の整理</a:t>
+              <a:t>課題認識の一致</a:t>
             </a:r>
           </a:p>
         </p:txBody>
@@ -4943,7 +5714,7 @@
                 </a:solidFill>
                 <a:latin typeface="Noto Sans"/>
               </a:rPr>
-              <a:t>CMG が抱える会議・リサーチ業務の非効率ポイントを確認</a:t>
+              <a:t>CMGの調査業務における人手依存・属人化・長いリードタイムについて認識が共有された</a:t>
             </a:r>
           </a:p>
         </p:txBody>
@@ -5021,7 +5792,7 @@
                 </a:solidFill>
                 <a:latin typeface="Noto Sans"/>
               </a:rPr>
-              <a:t>02　Notta ソリューション</a:t>
+              <a:t>協業スコープの絞り込み</a:t>
             </a:r>
           </a:p>
         </p:txBody>
@@ -5054,7 +5825,7 @@
                 </a:solidFill>
                 <a:latin typeface="Noto Sans"/>
               </a:rPr>
-              <a:t>AI 文字起こし・要約・翻訳機能のご紹介</a:t>
+              <a:t>「会議音声 → 調査設計AI → アンケート配信」のフロー連携をミニマムスコープとして合意</a:t>
             </a:r>
           </a:p>
         </p:txBody>
@@ -5132,7 +5903,7 @@
                 </a:solidFill>
                 <a:latin typeface="Noto Sans"/>
               </a:rPr>
-              <a:t>03　導入効果・ROI</a:t>
+              <a:t>インターフェース方針</a:t>
             </a:r>
           </a:p>
         </p:txBody>
@@ -5165,7 +5936,7 @@
                 </a:solidFill>
                 <a:latin typeface="Noto Sans"/>
               </a:rPr>
-              <a:t>時間削減・品質向上・コスト試算</a:t>
+              <a:t>NottaのUI/UXをそのままクライアントに提供し、データ連携はAPI経由で行うモデルに合意</a:t>
             </a:r>
           </a:p>
         </p:txBody>
@@ -5243,7 +6014,7 @@
                 </a:solidFill>
                 <a:latin typeface="Noto Sans"/>
               </a:rPr>
-              <a:t>04　導入ステップ</a:t>
+              <a:t>次のアクション</a:t>
             </a:r>
           </a:p>
         </p:txBody>
@@ -5276,7 +6047,7 @@
                 </a:solidFill>
                 <a:latin typeface="Noto Sans"/>
               </a:rPr>
-              <a:t>パイロット導入から全社展開までのロードマップ</a:t>
+              <a:t>4月頭に両社プロダクトのデモ・要件整理MTGを設定。PoC予算感も含めて議論</a:t>
             </a:r>
           </a:p>
         </p:txBody>
@@ -5335,7 +6106,7 @@
                 </a:solidFill>
                 <a:latin typeface="Noto Sans"/>
               </a:rPr>
-              <a:t>CMG の現状課題</a:t>
+              <a:t>CMGを取り巻く市場環境</a:t>
             </a:r>
           </a:p>
         </p:txBody>
@@ -5411,7 +6182,7 @@
                 </a:solidFill>
                 <a:latin typeface="Noto Sans"/>
               </a:rPr>
-              <a:t>年間数千件の調査・面談で発生する「記録コスト」が業務全体の生産性を圧迫している</a:t>
+              <a:t>従来型リサーチ市場はAI・XMプラットフォームの台頭でシュリンク局面へ。プラットフォームへの転換が急務</a:t>
             </a:r>
           </a:p>
         </p:txBody>
@@ -5489,7 +6260,7 @@
                 </a:solidFill>
                 <a:latin typeface="Noto Sans"/>
               </a:rPr>
-              <a:t>手動議事録の工数</a:t>
+              <a:t>定量調査のセルフ化加速</a:t>
             </a:r>
           </a:p>
         </p:txBody>
@@ -5522,7 +6293,7 @@
                 </a:solidFill>
                 <a:latin typeface="Noto Sans"/>
               </a:rPr>
-              <a:t>1時間の面談につき平均 30〜60 分の清書時間が発生。月換算で数十時間のロス</a:t>
+              <a:t>Qualtrics等のXMプラットフォームが国内でも拡大。従来の受託アドホック調査のシェアが低下局面に入っている</a:t>
             </a:r>
           </a:p>
         </p:txBody>
@@ -5600,7 +6371,7 @@
                 </a:solidFill>
                 <a:latin typeface="Noto Sans"/>
               </a:rPr>
-              <a:t>情報の属人化</a:t>
+              <a:t>定性調査にも「速さ×深さ」要求</a:t>
             </a:r>
           </a:p>
         </p:txBody>
@@ -5633,7 +6404,7 @@
                 </a:solidFill>
                 <a:latin typeface="Noto Sans"/>
               </a:rPr>
-              <a:t>担当者が異なると記録の粒度や表現にばらつき。ナレッジ共有が困難</a:t>
+              <a:t>FGI・IDIの結果を待つ余裕がなくなり、リアルタイムに近い意思決定インサイトが求められている</a:t>
             </a:r>
           </a:p>
         </p:txBody>
@@ -5711,7 +6482,7 @@
                 </a:solidFill>
                 <a:latin typeface="Noto Sans"/>
               </a:rPr>
-              <a:t>多言語対応コスト</a:t>
+              <a:t>AIが調査設計を代替し始めた</a:t>
             </a:r>
           </a:p>
         </p:txBody>
@@ -5744,7 +6515,7 @@
                 </a:solidFill>
                 <a:latin typeface="Noto Sans"/>
               </a:rPr>
-              <a:t>海外クライアント案件での翻訳依頼に都度コストが発生</a:t>
+              <a:t>CMG社内検証でも「10年のリサーチャーと同水準の調査設計」をAIが実現。高付加価値領域のAI代替が現実化</a:t>
             </a:r>
           </a:p>
         </p:txBody>
@@ -5822,7 +6593,7 @@
                 </a:solidFill>
                 <a:latin typeface="Noto Sans"/>
               </a:rPr>
-              <a:t>データ活用の機会損失</a:t>
+              <a:t>リードタイムへの圧力</a:t>
             </a:r>
           </a:p>
         </p:txBody>
@@ -5855,7 +6626,7 @@
                 </a:solidFill>
                 <a:latin typeface="Noto Sans"/>
               </a:rPr>
-              <a:t>録音・テキストが整備されていないため、過去案件のインサイト再利用ができていない</a:t>
+              <a:t>調査企画から納品まで7ステップ以上・数週間を要する現状に対し、クライアントの意思決定スピードは加速。構造的なミスマッチ</a:t>
             </a:r>
           </a:p>
         </p:txBody>
@@ -5914,7 +6685,7 @@
                 </a:solidFill>
                 <a:latin typeface="Noto Sans"/>
               </a:rPr>
-              <a:t>Notta とは</a:t>
+              <a:t>CMGの戦略的方向性</a:t>
             </a:r>
           </a:p>
         </p:txBody>
@@ -5990,7 +6761,7 @@
                 </a:solidFill>
                 <a:latin typeface="Noto Sans"/>
               </a:rPr>
-              <a:t>世界 100 カ国・700 万ユーザーが利用する、音声→テキスト→インサイト変換の AI プラットフォーム</a:t>
+              <a:t>受託リサーチからリサーチ・プラットフォームへ。クライアントの意思決定全プロセスを自動化する「国産XM」を目指す</a:t>
             </a:r>
           </a:p>
         </p:txBody>
@@ -6068,7 +6839,7 @@
                 </a:solidFill>
                 <a:latin typeface="Noto Sans"/>
               </a:rPr>
-              <a:t>リアルタイム文字起こし</a:t>
+              <a:t>コンパウンドプロダクト戦略</a:t>
             </a:r>
           </a:p>
         </p:txBody>
@@ -6101,7 +6872,7 @@
                 </a:solidFill>
                 <a:latin typeface="Noto Sans"/>
               </a:rPr>
-              <a:t>Zoom / Teams / Google Meet と連携。話しながらその場でテキスト化。精度 95% 以上（日本語）</a:t>
+              <a:t>「秋雲（セルフアンケート）」「リサーチャー向けプロダクト（プロト完成）」「顧客ポータル」を統合したプラットフォームへ</a:t>
             </a:r>
           </a:p>
         </p:txBody>
@@ -6179,7 +6950,7 @@
                 </a:solidFill>
                 <a:latin typeface="Noto Sans"/>
               </a:rPr>
-              <a:t>AI 要約・議事録生成</a:t>
+              <a:t>調査プロセスの自動化</a:t>
             </a:r>
           </a:p>
         </p:txBody>
@@ -6212,7 +6983,7 @@
                 </a:solidFill>
                 <a:latin typeface="Noto Sans"/>
               </a:rPr>
-              <a:t>会議終了後 1 分で要約・アクションアイテム・決定事項を自動抽出</a:t>
+              <a:t>現状7ステップ（課題認識→仮説化→調査設計→配信→回収→分析→レポート）を「設計確認」「結果確認」の2ステップに圧縮</a:t>
             </a:r>
           </a:p>
         </p:txBody>
@@ -6290,7 +7061,7 @@
                 </a:solidFill>
                 <a:latin typeface="Noto Sans"/>
               </a:rPr>
-              <a:t>58 言語対応・翻訳</a:t>
+              <a:t>グループ30社への横展開</a:t>
             </a:r>
           </a:p>
         </p:txBody>
@@ -6323,7 +7094,7 @@
                 </a:solidFill>
                 <a:latin typeface="Noto Sans"/>
               </a:rPr>
-              <a:t>日英中韓など 58 言語の文字起こし・翻訳に対応。グローバル案件もワンストップ</a:t>
+              <a:t>子会社30社にわたるグループ会社のナレッジ・データを統合し、横断的な競争優位を構築</a:t>
             </a:r>
           </a:p>
         </p:txBody>
@@ -6401,7 +7172,7 @@
                 </a:solidFill>
                 <a:latin typeface="Noto Sans"/>
               </a:rPr>
-              <a:t>チーム共有・検索</a:t>
+              <a:t>収益モデルの転換</a:t>
             </a:r>
           </a:p>
         </p:txBody>
@@ -6434,7 +7205,7 @@
                 </a:solidFill>
                 <a:latin typeface="Noto Sans"/>
               </a:rPr>
-              <a:t>全録音・テキストをクラウド保管。キーワード検索で過去案件を即座に参照可能</a:t>
+              <a:t>単発受託（数十万〜100万円）からSaaSプラットフォーム型の継続収益へ。クライアントの自走化を支援する新たなマネタイズ軸</a:t>
             </a:r>
           </a:p>
         </p:txBody>
@@ -6493,7 +7264,7 @@
                 </a:solidFill>
                 <a:latin typeface="Noto Sans"/>
               </a:rPr>
-              <a:t>CMG × Notta：主な活用シーン</a:t>
+              <a:t>CMGの現場課題：音声データ周辺のボトルネック</a:t>
             </a:r>
           </a:p>
         </p:txBody>
@@ -6569,7 +7340,7 @@
                 </a:solidFill>
                 <a:latin typeface="Noto Sans"/>
               </a:rPr>
-              <a:t>リサーチ・営業・コーポレートの全部門で導入効果が見込める</a:t>
+              <a:t>調査の最上流「会議・ブリーフィング」のデータが構造化されないまま失われ、下流全体の品質とスピードを制約している</a:t>
             </a:r>
           </a:p>
         </p:txBody>
@@ -6647,7 +7418,7 @@
                 </a:solidFill>
                 <a:latin typeface="Noto Sans"/>
               </a:rPr>
-              <a:t>定性調査（FGI・IDI）</a:t>
+              <a:t>会議データが分断・消滅</a:t>
             </a:r>
           </a:p>
         </p:txBody>
@@ -6680,7 +7451,7 @@
                 </a:solidFill>
                 <a:latin typeface="Noto Sans"/>
               </a:rPr>
-              <a:t>インタビュー音声を自動文字起こし→コーダー工数を大幅削減。テープ起こし外注費の内製化</a:t>
+              <a:t>商品企画会議・クライアントブリーフィングはGoogle Meet等で実施されるが、音声データは蓄積されず意思決定の文脈が失われる</a:t>
             </a:r>
           </a:p>
         </p:txBody>
@@ -6758,7 +7529,7 @@
                 </a:solidFill>
                 <a:latin typeface="Noto Sans"/>
               </a:rPr>
-              <a:t>クライアント面談・提案</a:t>
+              <a:t>調査設計の属人化</a:t>
             </a:r>
           </a:p>
         </p:txBody>
@@ -6791,7 +7562,7 @@
                 </a:solidFill>
                 <a:latin typeface="Noto Sans"/>
               </a:rPr>
-              <a:t>商談録音→要約を即日共有。営業レポート作成時間を 70% 削減</a:t>
+              <a:t>録音→文字起こし→分析→コーディングの各工程が担当者依存。品質・スピードにばらつきが生じている</a:t>
             </a:r>
           </a:p>
         </p:txBody>
@@ -6869,7 +7640,7 @@
                 </a:solidFill>
                 <a:latin typeface="Noto Sans"/>
               </a:rPr>
-              <a:t>社内会議・プロジェクト管理</a:t>
+              <a:t>調査票の質が不安定</a:t>
             </a:r>
           </a:p>
         </p:txBody>
@@ -6902,7 +7673,7 @@
                 </a:solidFill>
                 <a:latin typeface="Noto Sans"/>
               </a:rPr>
-              <a:t>議事録の作成・共有・検索を自動化。情報共有ミスをゼロに</a:t>
+              <a:t>マーケター・新規事業担当はリサーチの専門家ではないため、聞きたいことが適切に質問化できていないケースが多い</a:t>
             </a:r>
           </a:p>
         </p:txBody>
@@ -6980,7 +7751,7 @@
                 </a:solidFill>
                 <a:latin typeface="Noto Sans"/>
               </a:rPr>
-              <a:t>海外案件・グローバル連携</a:t>
+              <a:t>上流の意思決定のベクトルズレ</a:t>
             </a:r>
           </a:p>
         </p:txBody>
@@ -7013,7 +7784,7 @@
                 </a:solidFill>
                 <a:latin typeface="Noto Sans"/>
               </a:rPr>
-              <a:t>多言語文字起こしで海外クライアントとのコミュニケーションコストを削減</a:t>
+              <a:t>部長以上が求めるインサイトと、下流で設計された調査票のベクトルがずれて納品されるケースが頻発</a:t>
             </a:r>
           </a:p>
         </p:txBody>
@@ -7072,7 +7843,7 @@
                 </a:solidFill>
                 <a:latin typeface="Noto Sans"/>
               </a:rPr>
-              <a:t>導入効果・ROI シミュレーション</a:t>
+              <a:t>協業で実現する「音声起点リサーチ自動化フロー」</a:t>
             </a:r>
           </a:p>
         </p:txBody>
@@ -7148,7 +7919,7 @@
                 </a:solidFill>
                 <a:latin typeface="Noto Sans"/>
               </a:rPr>
-              <a:t>100 名導入で年間約 2,400 時間・1,200 万円相当の工数削減効果が見込める</a:t>
+              <a:t>会議の音声データをNottaが構造化し、CMGの調査設計AIに渡すことで、ミーティング終了即・調査設計完成を実現する</a:t>
             </a:r>
           </a:p>
         </p:txBody>
@@ -7226,7 +7997,7 @@
                 </a:solidFill>
                 <a:latin typeface="Noto Sans"/>
               </a:rPr>
-              <a:t>議事録作成工数</a:t>
+              <a:t>STEP 1｜音声取得・構造化（Notta）</a:t>
             </a:r>
           </a:p>
         </p:txBody>
@@ -7259,8 +8030,7 @@
                 </a:solidFill>
                 <a:latin typeface="Noto Sans"/>
               </a:rPr>
-              <a:t>1人あたり月 4 時間削減 × 100名 = 月 400 時間削減
-（時給 5,000 円換算で月 200 万円相当）</a:t>
+              <a:t>クライアントの商品企画会議・ブリーフィングをNottaで録音→高精度日本語ASRで文字起こし→話者分離・要約・示唆抽出</a:t>
             </a:r>
           </a:p>
         </p:txBody>
@@ -7338,7 +8108,7 @@
                 </a:solidFill>
                 <a:latin typeface="Noto Sans"/>
               </a:rPr>
-              <a:t>テープ起こし外注費</a:t>
+              <a:t>STEP 2｜調査設計AI連携（CMG）</a:t>
             </a:r>
           </a:p>
         </p:txBody>
@@ -7371,8 +8141,7 @@
                 </a:solidFill>
                 <a:latin typeface="Noto Sans"/>
               </a:rPr>
-              <a:t>年間外注費の最大 80% を内製化。
-仮に年 300 万円の外注費なら → 240 万円削減</a:t>
+              <a:t>Nottaが出力したテキスト/JSONをCMGの調査設計AIに渡し、調査手法・設問・分岐ロジックを自動生成。人間は「承認」のみ</a:t>
             </a:r>
           </a:p>
         </p:txBody>
@@ -7450,7 +8219,7 @@
                 </a:solidFill>
                 <a:latin typeface="Noto Sans"/>
               </a:rPr>
-              <a:t>翻訳コスト削減</a:t>
+              <a:t>STEP 3｜配信・回収（CMG「秋雲」等）</a:t>
             </a:r>
           </a:p>
         </p:txBody>
@@ -7483,8 +8252,7 @@
                 </a:solidFill>
                 <a:latin typeface="Noto Sans"/>
               </a:rPr>
-              <a:t>AI 翻訳機能活用で翻訳依頼件数を 50% 削減。
-年間 100 万円規模のコスト圧縮</a:t>
+              <a:t>設計済みアンケートをMA/秋雲で自動配信。N数確保・回収も自動化。インターフェースはCMGの既存サービスをそのまま活用</a:t>
             </a:r>
           </a:p>
         </p:txBody>
@@ -7562,7 +8330,7 @@
                 </a:solidFill>
                 <a:latin typeface="Noto Sans"/>
               </a:rPr>
-              <a:t>Notta 年間費用（試算）</a:t>
+              <a:t>STEP 4｜レポート・意思決定（クライアント）</a:t>
             </a:r>
           </a:p>
         </p:txBody>
@@ -7595,9 +8363,7 @@
                 </a:solidFill>
                 <a:latin typeface="Noto Sans"/>
               </a:rPr>
-              <a:t>Business プラン：¥2,200/月/名 × 100名
-= 年間 264 万円
-→ ROI は初年度から黒字化</a:t>
+              <a:t>回答データからLLMがレポートのたたき台を自動生成。クライアントが確認・意思決定→次の企画サイクルへ即座に移行</a:t>
             </a:r>
           </a:p>
         </p:txBody>
@@ -7656,7 +8422,7 @@
                 </a:solidFill>
                 <a:latin typeface="Noto Sans"/>
               </a:rPr>
-              <a:t>セキュリティ・コンプライアンス</a:t>
+              <a:t>ユーザーセグメント別の価値提供</a:t>
             </a:r>
           </a:p>
         </p:txBody>
@@ -7732,7 +8498,7 @@
                 </a:solidFill>
                 <a:latin typeface="Noto Sans"/>
               </a:rPr>
-              <a:t>機密性の高いリサーチデータも安心して預けられるエンタープライズグレードのセキュリティ</a:t>
+              <a:t>85%の「自動化ニーズ」層と15%の「コントロールニーズ」層に対し、テンプレートとカスタム設定で対応を分ける</a:t>
             </a:r>
           </a:p>
         </p:txBody>
@@ -7810,7 +8576,7 @@
                 </a:solidFill>
                 <a:latin typeface="Noto Sans"/>
               </a:rPr>
-              <a:t>データ暗号化</a:t>
+              <a:t>85%｜マーケター・新規事業担当</a:t>
             </a:r>
           </a:p>
         </p:txBody>
@@ -7843,7 +8609,7 @@
                 </a:solidFill>
                 <a:latin typeface="Noto Sans"/>
               </a:rPr>
-              <a:t>転送・保存ともに AES-256 暗号化。通信は TLS 1.2 以上</a:t>
+              <a:t>調査のプロではない層。「目的・背景・経緯を入力したら調査設計が自動完成」を求める。テンプレート化されたフローで完全自動化</a:t>
             </a:r>
           </a:p>
         </p:txBody>
@@ -7921,7 +8687,7 @@
                 </a:solidFill>
                 <a:latin typeface="Noto Sans"/>
               </a:rPr>
-              <a:t>アクセス制御</a:t>
+              <a:t>15%｜リサーチャー・コンサル上位層</a:t>
             </a:r>
           </a:p>
         </p:txBody>
@@ -7954,7 +8720,7 @@
                 </a:solidFill>
                 <a:latin typeface="Noto Sans"/>
               </a:rPr>
-              <a:t>ロールベースアクセス管理（RBAC）。部門・プロジェクト単位での権限設定が可能</a:t>
+              <a:t>仮説検証のプロ。LLMのアウトプットに対して自ら仮説を立てて検証したい。Nottaブレインのプロンプトカスタマイズで対応</a:t>
             </a:r>
           </a:p>
         </p:txBody>
@@ -8032,7 +8798,7 @@
                 </a:solidFill>
                 <a:latin typeface="Noto Sans"/>
               </a:rPr>
-              <a:t>個人情報保護</a:t>
+              <a:t>Notta側のプロンプトテンプレ活用</a:t>
             </a:r>
           </a:p>
         </p:txBody>
@@ -8065,7 +8831,7 @@
                 </a:solidFill>
                 <a:latin typeface="Noto Sans"/>
               </a:rPr>
-              <a:t>GDPR・個人情報保護法に準拠。データの保存地域（日本/米国）を選択可能</a:t>
+              <a:t>CMGリサーチャーが設計済みのプロンプトテンプレートをNottaブレインに組み込み、アウトプットの方向性・粒度を標準化</a:t>
             </a:r>
           </a:p>
         </p:txBody>
@@ -8143,7 +8909,7 @@
                 </a:solidFill>
                 <a:latin typeface="Noto Sans"/>
               </a:rPr>
-              <a:t>SOC2 Type II 認証</a:t>
+              <a:t>過去データによる品質担保</a:t>
             </a:r>
           </a:p>
         </p:txBody>
@@ -8176,7 +8942,7 @@
                 </a:solidFill>
                 <a:latin typeface="Noto Sans"/>
               </a:rPr>
-              <a:t>第三者機関によるセキュリティ監査済み。エンタープライズ契約では NDA・DPA も締結可能</a:t>
+              <a:t>CMGが保有する過去調査テキストデータをRAG的に活用。「同種調査ならこの設計が有効」という経験則をAIに継承</a:t>
             </a:r>
           </a:p>
         </p:txBody>
@@ -8235,7 +9001,7 @@
                 </a:solidFill>
                 <a:latin typeface="Noto Sans"/>
               </a:rPr>
-              <a:t>導入ステップ</a:t>
+              <a:t>インターフェース・技術連携方針</a:t>
             </a:r>
           </a:p>
         </p:txBody>
@@ -8311,7 +9077,7 @@
                 </a:solidFill>
                 <a:latin typeface="Noto Sans"/>
               </a:rPr>
-              <a:t>最短 2 週間のパイロットから始め、3 ヶ月で全社展開を実現するロードマップ</a:t>
+              <a:t>NottaのUI/UXをそのままクライアントに提供。CMGはAPIでデータを受け取り後工程を自走させるエコシステム型連携</a:t>
             </a:r>
           </a:p>
         </p:txBody>
@@ -8325,16 +9091,18 @@
         <p:spPr>
           <a:xfrm>
             <a:off x="548640" y="1897380"/>
-            <a:ext cx="3587496" cy="4640580"/>
+            <a:ext cx="5463540" cy="2237994"/>
           </a:xfrm>
           <a:prstGeom prst="rect">
             <a:avLst/>
           </a:prstGeom>
           <a:solidFill>
-            <a:srgbClr val="F5F5F5"/>
+            <a:srgbClr val="FFFFFF"/>
           </a:solidFill>
-          <a:ln>
-            <a:noFill/>
+          <a:ln w="9525">
+            <a:solidFill>
+              <a:srgbClr val="E0E0E0"/>
+            </a:solidFill>
           </a:ln>
         </p:spPr>
         <p:style>
@@ -8368,7 +9136,7 @@
         <p:spPr>
           <a:xfrm>
             <a:off x="713232" y="2061972"/>
-            <a:ext cx="3258312" cy="347472"/>
+            <a:ext cx="5134356" cy="347472"/>
           </a:xfrm>
           <a:prstGeom prst="rect">
             <a:avLst/>
@@ -8387,7 +9155,7 @@
                 </a:solidFill>
                 <a:latin typeface="Noto Sans"/>
               </a:rPr>
-              <a:t>Phase 1｜パイロット導入（〜1ヶ月）</a:t>
+              <a:t>UI：Notta as Front-end</a:t>
             </a:r>
           </a:p>
         </p:txBody>
@@ -8401,7 +9169,7 @@
         <p:spPr>
           <a:xfrm>
             <a:off x="713232" y="2446020"/>
-            <a:ext cx="3258312" cy="3927348"/>
+            <a:ext cx="5134356" cy="1524762"/>
           </a:xfrm>
           <a:prstGeom prst="rect">
             <a:avLst/>
@@ -8420,7 +9188,7 @@
                 </a:solidFill>
                 <a:latin typeface="Noto Sans"/>
               </a:rPr>
-              <a:t>対象部門 10〜20 名でトライアル実施。使用感・業務フィット確認。導入サポート・トレーニング提供</a:t>
+              <a:t>クライアントはNottaをそのまま使用。CMGが独自UIを開発するコストを削減し、Nottaの既存ユーザーベースもそのまま活用可能</a:t>
             </a:r>
           </a:p>
         </p:txBody>
@@ -8433,17 +9201,19 @@
         </p:nvSpPr>
         <p:spPr>
           <a:xfrm>
-            <a:off x="4300728" y="1897380"/>
-            <a:ext cx="3587496" cy="4640580"/>
+            <a:off x="6176772" y="1897380"/>
+            <a:ext cx="5463540" cy="2237994"/>
           </a:xfrm>
           <a:prstGeom prst="rect">
             <a:avLst/>
           </a:prstGeom>
           <a:solidFill>
-            <a:srgbClr val="F5F5F5"/>
+            <a:srgbClr val="FFFFFF"/>
           </a:solidFill>
-          <a:ln>
-            <a:noFill/>
+          <a:ln w="9525">
+            <a:solidFill>
+              <a:srgbClr val="E0E0E0"/>
+            </a:solidFill>
           </a:ln>
         </p:spPr>
         <p:style>
@@ -8476,8 +9246,8 @@
         </p:nvSpPr>
         <p:spPr>
           <a:xfrm>
-            <a:off x="4465320" y="2061972"/>
-            <a:ext cx="3258312" cy="347472"/>
+            <a:off x="6341364" y="2061972"/>
+            <a:ext cx="5134356" cy="347472"/>
           </a:xfrm>
           <a:prstGeom prst="rect">
             <a:avLst/>
@@ -8496,7 +9266,7 @@
                 </a:solidFill>
                 <a:latin typeface="Noto Sans"/>
               </a:rPr>
-              <a:t>Phase 2｜効果測定・最適化（2ヶ月目）</a:t>
+              <a:t>データ連携：API/データ出力</a:t>
             </a:r>
           </a:p>
         </p:txBody>
@@ -8509,8 +9279,8 @@
         </p:nvSpPr>
         <p:spPr>
           <a:xfrm>
-            <a:off x="4465320" y="2446020"/>
-            <a:ext cx="3258312" cy="3927348"/>
+            <a:off x="6341364" y="2446020"/>
+            <a:ext cx="5134356" cy="1524762"/>
           </a:xfrm>
           <a:prstGeom prst="rect">
             <a:avLst/>
@@ -8529,7 +9299,7 @@
                 </a:solidFill>
                 <a:latin typeface="Noto Sans"/>
               </a:rPr>
-              <a:t>KPI（時間削減・満足度）を計測。ワークフロー・テンプレートをカスタマイズ</a:t>
+              <a:t>NottaがテキストデータをAPI・JSONで出力→CMGの調査設計AI・秋雲・顧客ポータルに連携。後工程はCMG側システムが自律稼働</a:t>
             </a:r>
           </a:p>
         </p:txBody>
@@ -8542,17 +9312,19 @@
         </p:nvSpPr>
         <p:spPr>
           <a:xfrm>
-            <a:off x="8052816" y="1897380"/>
-            <a:ext cx="3587496" cy="4640580"/>
+            <a:off x="548640" y="4299966"/>
+            <a:ext cx="5463540" cy="2237994"/>
           </a:xfrm>
           <a:prstGeom prst="rect">
             <a:avLst/>
           </a:prstGeom>
           <a:solidFill>
-            <a:srgbClr val="F5F5F5"/>
+            <a:srgbClr val="FFFFFF"/>
           </a:solidFill>
-          <a:ln>
-            <a:noFill/>
+          <a:ln w="9525">
+            <a:solidFill>
+              <a:srgbClr val="E0E0E0"/>
+            </a:solidFill>
           </a:ln>
         </p:spPr>
         <p:style>
@@ -8585,8 +9357,8 @@
         </p:nvSpPr>
         <p:spPr>
           <a:xfrm>
-            <a:off x="8217408" y="2061972"/>
-            <a:ext cx="3258312" cy="347472"/>
+            <a:off x="713232" y="4464558"/>
+            <a:ext cx="5134356" cy="347472"/>
           </a:xfrm>
           <a:prstGeom prst="rect">
             <a:avLst/>
@@ -8605,7 +9377,7 @@
                 </a:solidFill>
                 <a:latin typeface="Noto Sans"/>
               </a:rPr>
-              <a:t>Phase 3｜全社展開（3ヶ月目〜）</a:t>
+              <a:t>ハードウェアはスコープ外</a:t>
             </a:r>
           </a:p>
         </p:txBody>
@@ -8618,8 +9390,8 @@
         </p:nvSpPr>
         <p:spPr>
           <a:xfrm>
-            <a:off x="8217408" y="2446020"/>
-            <a:ext cx="3258312" cy="3927348"/>
+            <a:off x="713232" y="4848606"/>
+            <a:ext cx="5134356" cy="1524762"/>
           </a:xfrm>
           <a:prstGeom prst="rect">
             <a:avLst/>
@@ -8638,7 +9410,118 @@
                 </a:solidFill>
                 <a:latin typeface="Noto Sans"/>
               </a:rPr>
-              <a:t>全部門へのロールアウト。IT 部門との SSO / API 連携。管理者研修の実施</a:t>
+              <a:t>Meeting Owl等のハードウェア連携はコスト・情報管理の観点から現段階ではスコープ外。ソフトウェアレイヤーで解決する方針に合意</a:t>
+            </a:r>
+          </a:p>
+        </p:txBody>
+      </p:sp>
+      <p:sp>
+        <p:nvSpPr>
+          <p:cNvPr id="14" name="Rectangle 13"/>
+          <p:cNvSpPr/>
+          <p:nvPr/>
+        </p:nvSpPr>
+        <p:spPr>
+          <a:xfrm>
+            <a:off x="6176772" y="4299966"/>
+            <a:ext cx="5463540" cy="2237994"/>
+          </a:xfrm>
+          <a:prstGeom prst="rect">
+            <a:avLst/>
+          </a:prstGeom>
+          <a:solidFill>
+            <a:srgbClr val="FFFFFF"/>
+          </a:solidFill>
+          <a:ln w="9525">
+            <a:solidFill>
+              <a:srgbClr val="E0E0E0"/>
+            </a:solidFill>
+          </a:ln>
+        </p:spPr>
+        <p:style>
+          <a:lnRef idx="1">
+            <a:schemeClr val="accent1"/>
+          </a:lnRef>
+          <a:fillRef idx="3">
+            <a:schemeClr val="accent1"/>
+          </a:fillRef>
+          <a:effectRef idx="2">
+            <a:schemeClr val="accent1"/>
+          </a:effectRef>
+          <a:fontRef idx="minor">
+            <a:schemeClr val="lt1"/>
+          </a:fontRef>
+        </p:style>
+        <p:txBody>
+          <a:bodyPr rtlCol="0" anchor="ctr"/>
+          <a:lstStyle/>
+          <a:p>
+            <a:pPr algn="ctr"/>
+          </a:p>
+        </p:txBody>
+      </p:sp>
+      <p:sp>
+        <p:nvSpPr>
+          <p:cNvPr id="15" name="TextBox 14"/>
+          <p:cNvSpPr txBox="1"/>
+          <p:nvPr/>
+        </p:nvSpPr>
+        <p:spPr>
+          <a:xfrm>
+            <a:off x="6341364" y="4464558"/>
+            <a:ext cx="5134356" cy="347472"/>
+          </a:xfrm>
+          <a:prstGeom prst="rect">
+            <a:avLst/>
+          </a:prstGeom>
+          <a:noFill/>
+        </p:spPr>
+        <p:txBody>
+          <a:bodyPr wrap="square"/>
+          <a:lstStyle/>
+          <a:p>
+            <a:pPr algn="l"/>
+            <a:r>
+              <a:rPr sz="1800" b="1">
+                <a:solidFill>
+                  <a:srgbClr val="2180FF"/>
+                </a:solidFill>
+                <a:latin typeface="Noto Sans"/>
+              </a:rPr>
+              <a:t>開発スピードへの配慮</a:t>
+            </a:r>
+          </a:p>
+        </p:txBody>
+      </p:sp>
+      <p:sp>
+        <p:nvSpPr>
+          <p:cNvPr id="16" name="TextBox 15"/>
+          <p:cNvSpPr txBox="1"/>
+          <p:nvPr/>
+        </p:nvSpPr>
+        <p:spPr>
+          <a:xfrm>
+            <a:off x="6341364" y="4848606"/>
+            <a:ext cx="5134356" cy="1524762"/>
+          </a:xfrm>
+          <a:prstGeom prst="rect">
+            <a:avLst/>
+          </a:prstGeom>
+          <a:noFill/>
+        </p:spPr>
+        <p:txBody>
+          <a:bodyPr wrap="square"/>
+          <a:lstStyle/>
+          <a:p>
+            <a:pPr algn="l"/>
+            <a:r>
+              <a:rPr sz="1200" b="0">
+                <a:solidFill>
+                  <a:srgbClr val="262626"/>
+                </a:solidFill>
+                <a:latin typeface="Noto Sans"/>
+              </a:rPr>
+              <a:t>CMG側のエンジニアリソースは限定的。Notta側はAPI・SDK・プロンプトテンプレートを提供し、CMG側の実装コストを最小化</a:t>
             </a:r>
           </a:p>
         </p:txBody>
@@ -8697,7 +9580,7 @@
                 </a:solidFill>
                 <a:latin typeface="Noto Sans"/>
               </a:rPr>
-              <a:t>プラン・価格</a:t>
+              <a:t>協業がもたらす競争優位性</a:t>
             </a:r>
           </a:p>
         </p:txBody>
@@ -8773,7 +9656,7 @@
                 </a:solidFill>
                 <a:latin typeface="Noto Sans"/>
               </a:rPr>
-              <a:t>チーム規模と用途に合わせた柔軟なプランで、スモールスタートから全社展開まで対応</a:t>
+              <a:t>Notta × CMGで「国産XMプラットフォーム」のファーストペンギンとなり、リサーチ業界のAI活用をリードする</a:t>
             </a:r>
           </a:p>
         </p:txBody>
@@ -8787,16 +9670,18 @@
         <p:spPr>
           <a:xfrm>
             <a:off x="548640" y="1897380"/>
-            <a:ext cx="3587496" cy="4640580"/>
+            <a:ext cx="5463540" cy="2237994"/>
           </a:xfrm>
           <a:prstGeom prst="rect">
             <a:avLst/>
           </a:prstGeom>
           <a:solidFill>
-            <a:srgbClr val="F5F5F5"/>
+            <a:srgbClr val="FFFFFF"/>
           </a:solidFill>
-          <a:ln>
-            <a:noFill/>
+          <a:ln w="9525">
+            <a:solidFill>
+              <a:srgbClr val="E0E0E0"/>
+            </a:solidFill>
           </a:ln>
         </p:spPr>
         <p:style>
@@ -8830,7 +9715,7 @@
         <p:spPr>
           <a:xfrm>
             <a:off x="713232" y="2061972"/>
-            <a:ext cx="3258312" cy="347472"/>
+            <a:ext cx="5134356" cy="347472"/>
           </a:xfrm>
           <a:prstGeom prst="rect">
             <a:avLst/>
@@ -8849,7 +9734,7 @@
                 </a:solidFill>
                 <a:latin typeface="Noto Sans"/>
               </a:rPr>
-              <a:t>Pro プラン</a:t>
+              <a:t>CMGへのインパクト①｜新収益軸</a:t>
             </a:r>
           </a:p>
         </p:txBody>
@@ -8863,7 +9748,7 @@
         <p:spPr>
           <a:xfrm>
             <a:off x="713232" y="2446020"/>
-            <a:ext cx="3258312" cy="3927348"/>
+            <a:ext cx="5134356" cy="1524762"/>
           </a:xfrm>
           <a:prstGeom prst="rect">
             <a:avLst/>
@@ -8882,9 +9767,7 @@
                 </a:solidFill>
                 <a:latin typeface="Noto Sans"/>
               </a:rPr>
-              <a:t>¥2,200 / 月（年払い）
-文字起こし 1,800 分/月
-個人利用・小規模チーム向け</a:t>
+              <a:t>受託リサーチのシュリンクを補完する「プラットフォームSaaS」収益を確立。クライアントの自走化を支援する新マネタイズモデル</a:t>
             </a:r>
           </a:p>
         </p:txBody>
@@ -8897,17 +9780,19 @@
         </p:nvSpPr>
         <p:spPr>
           <a:xfrm>
-            <a:off x="4300728" y="1897380"/>
-            <a:ext cx="3587496" cy="4640580"/>
+            <a:off x="6176772" y="1897380"/>
+            <a:ext cx="5463540" cy="2237994"/>
           </a:xfrm>
           <a:prstGeom prst="rect">
             <a:avLst/>
           </a:prstGeom>
           <a:solidFill>
-            <a:srgbClr val="F5F5F5"/>
+            <a:srgbClr val="FFFFFF"/>
           </a:solidFill>
-          <a:ln>
-            <a:noFill/>
+          <a:ln w="9525">
+            <a:solidFill>
+              <a:srgbClr val="E0E0E0"/>
+            </a:solidFill>
           </a:ln>
         </p:spPr>
         <p:style>
@@ -8940,8 +9825,8 @@
         </p:nvSpPr>
         <p:spPr>
           <a:xfrm>
-            <a:off x="4465320" y="2061972"/>
-            <a:ext cx="3258312" cy="347472"/>
+            <a:off x="6341364" y="2061972"/>
+            <a:ext cx="5134356" cy="347472"/>
           </a:xfrm>
           <a:prstGeom prst="rect">
             <a:avLst/>
@@ -8960,7 +9845,7 @@
                 </a:solidFill>
                 <a:latin typeface="Noto Sans"/>
               </a:rPr>
-              <a:t>Business プラン</a:t>
+              <a:t>CMGへのインパクト②｜競争優位</a:t>
             </a:r>
           </a:p>
         </p:txBody>
@@ -8973,8 +9858,8 @@
         </p:nvSpPr>
         <p:spPr>
           <a:xfrm>
-            <a:off x="4465320" y="2446020"/>
-            <a:ext cx="3258312" cy="3927348"/>
+            <a:off x="6341364" y="2446020"/>
+            <a:ext cx="5134356" cy="1524762"/>
           </a:xfrm>
           <a:prstGeom prst="rect">
             <a:avLst/>
@@ -8993,9 +9878,7 @@
                 </a:solidFill>
                 <a:latin typeface="Noto Sans"/>
               </a:rPr>
-              <a:t>¥3,300 / 月（年払い）
-文字起こし 無制限
-チーム管理・SSO・優先サポート付き</a:t>
+              <a:t>音声→調査→レポートの完全自動フローを業界で初めて実装。国内リサーチ業界での「AI活用ファーストペンギン」としてのプレゼンス獲得</a:t>
             </a:r>
           </a:p>
         </p:txBody>
@@ -9008,17 +9891,19 @@
         </p:nvSpPr>
         <p:spPr>
           <a:xfrm>
-            <a:off x="8052816" y="1897380"/>
-            <a:ext cx="3587496" cy="4640580"/>
+            <a:off x="548640" y="4299966"/>
+            <a:ext cx="5463540" cy="2237994"/>
           </a:xfrm>
           <a:prstGeom prst="rect">
             <a:avLst/>
           </a:prstGeom>
           <a:solidFill>
-            <a:srgbClr val="F5F5F5"/>
+            <a:srgbClr val="FFFFFF"/>
           </a:solidFill>
-          <a:ln>
-            <a:noFill/>
+          <a:ln w="9525">
+            <a:solidFill>
+              <a:srgbClr val="E0E0E0"/>
+            </a:solidFill>
           </a:ln>
         </p:spPr>
         <p:style>
@@ -9051,8 +9936,8 @@
         </p:nvSpPr>
         <p:spPr>
           <a:xfrm>
-            <a:off x="8217408" y="2061972"/>
-            <a:ext cx="3258312" cy="347472"/>
+            <a:off x="713232" y="4464558"/>
+            <a:ext cx="5134356" cy="347472"/>
           </a:xfrm>
           <a:prstGeom prst="rect">
             <a:avLst/>
@@ -9071,7 +9956,7 @@
                 </a:solidFill>
                 <a:latin typeface="Noto Sans"/>
               </a:rPr>
-              <a:t>Enterprise プラン</a:t>
+              <a:t>Nottaへのインパクト①｜垂直統合</a:t>
             </a:r>
           </a:p>
         </p:txBody>
@@ -9084,8 +9969,8 @@
         </p:nvSpPr>
         <p:spPr>
           <a:xfrm>
-            <a:off x="8217408" y="2446020"/>
-            <a:ext cx="3258312" cy="3927348"/>
+            <a:off x="713232" y="4848606"/>
+            <a:ext cx="5134356" cy="1524762"/>
           </a:xfrm>
           <a:prstGeom prst="rect">
             <a:avLst/>
@@ -9104,9 +9989,118 @@
                 </a:solidFill>
                 <a:latin typeface="Noto Sans"/>
               </a:rPr>
-              <a:t>カスタム価格
-専任 CSM・SLA 保証
-オンプレ対応・API 連携・カスタム機能開発</a:t>
+              <a:t>リサーチ業界への深い垂直統合。単なる文字起こしツールからリサーチバリューチェーンの中核インフラへの進化</a:t>
+            </a:r>
+          </a:p>
+        </p:txBody>
+      </p:sp>
+      <p:sp>
+        <p:nvSpPr>
+          <p:cNvPr id="14" name="Rectangle 13"/>
+          <p:cNvSpPr/>
+          <p:nvPr/>
+        </p:nvSpPr>
+        <p:spPr>
+          <a:xfrm>
+            <a:off x="6176772" y="4299966"/>
+            <a:ext cx="5463540" cy="2237994"/>
+          </a:xfrm>
+          <a:prstGeom prst="rect">
+            <a:avLst/>
+          </a:prstGeom>
+          <a:solidFill>
+            <a:srgbClr val="FFFFFF"/>
+          </a:solidFill>
+          <a:ln w="9525">
+            <a:solidFill>
+              <a:srgbClr val="E0E0E0"/>
+            </a:solidFill>
+          </a:ln>
+        </p:spPr>
+        <p:style>
+          <a:lnRef idx="1">
+            <a:schemeClr val="accent1"/>
+          </a:lnRef>
+          <a:fillRef idx="3">
+            <a:schemeClr val="accent1"/>
+          </a:fillRef>
+          <a:effectRef idx="2">
+            <a:schemeClr val="accent1"/>
+          </a:effectRef>
+          <a:fontRef idx="minor">
+            <a:schemeClr val="lt1"/>
+          </a:fontRef>
+        </p:style>
+        <p:txBody>
+          <a:bodyPr rtlCol="0" anchor="ctr"/>
+          <a:lstStyle/>
+          <a:p>
+            <a:pPr algn="ctr"/>
+          </a:p>
+        </p:txBody>
+      </p:sp>
+      <p:sp>
+        <p:nvSpPr>
+          <p:cNvPr id="15" name="TextBox 14"/>
+          <p:cNvSpPr txBox="1"/>
+          <p:nvPr/>
+        </p:nvSpPr>
+        <p:spPr>
+          <a:xfrm>
+            <a:off x="6341364" y="4464558"/>
+            <a:ext cx="5134356" cy="347472"/>
+          </a:xfrm>
+          <a:prstGeom prst="rect">
+            <a:avLst/>
+          </a:prstGeom>
+          <a:noFill/>
+        </p:spPr>
+        <p:txBody>
+          <a:bodyPr wrap="square"/>
+          <a:lstStyle/>
+          <a:p>
+            <a:pPr algn="l"/>
+            <a:r>
+              <a:rPr sz="1800" b="1">
+                <a:solidFill>
+                  <a:srgbClr val="2180FF"/>
+                </a:solidFill>
+                <a:latin typeface="Noto Sans"/>
+              </a:rPr>
+              <a:t>Nottaへのインパクト②｜市場拡大</a:t>
+            </a:r>
+          </a:p>
+        </p:txBody>
+      </p:sp>
+      <p:sp>
+        <p:nvSpPr>
+          <p:cNvPr id="16" name="TextBox 15"/>
+          <p:cNvSpPr txBox="1"/>
+          <p:nvPr/>
+        </p:nvSpPr>
+        <p:spPr>
+          <a:xfrm>
+            <a:off x="6341364" y="4848606"/>
+            <a:ext cx="5134356" cy="1524762"/>
+          </a:xfrm>
+          <a:prstGeom prst="rect">
+            <a:avLst/>
+          </a:prstGeom>
+          <a:noFill/>
+        </p:spPr>
+        <p:txBody>
+          <a:bodyPr wrap="square"/>
+          <a:lstStyle/>
+          <a:p>
+            <a:pPr algn="l"/>
+            <a:r>
+              <a:rPr sz="1200" b="0">
+                <a:solidFill>
+                  <a:srgbClr val="262626"/>
+                </a:solidFill>
+                <a:latin typeface="Noto Sans"/>
+              </a:rPr>
+              <a:t>CMGの顧客基盤（事業会社マーケター・新規事業担当）への販路拡大。CMGとのジョイントソリューションで新規開拓を加速</a:t>
             </a:r>
           </a:p>
         </p:txBody>

</xml_diff>